<commit_message>
Retitle deck, add workshop repo QR slide, outline Part 0
Slide 1 becomes "Control C* Con Claude Code / MCP + Skills = Awesome",
and a new closing slide points at bm.biz/k8ssandra-claude-repo via QR.
Outline gains a Part 0 covering cluster description and NB workload start.

Co-Authored-By: Claude Opus 5 (1M context) <noreply@anthropic.com>
</commit_message>
<xml_diff>
--- a/k8ssandra-reference-architecture.pptx
+++ b/k8ssandra-reference-architecture.pptx
@@ -15,6 +15,7 @@
     <p:sldId id="262" r:id="rId9"/>
     <p:sldId id="264" r:id="rId10"/>
     <p:sldId id="265" r:id="rId11"/>
+    <p:sldId id="266" r:id="rId12"/>
   </p:sldIdLst>
   <p:sldSz cx="12192000" cy="6858000"/>
   <p:notesSz cx="6858000" cy="9144000"/>
@@ -311,7 +312,7 @@
           <a:p>
             <a:fld id="{5BCAD085-E8A6-8845-BD4E-CB4CCA059FC4}" type="datetimeFigureOut">
               <a:rPr lang="en-US" smtClean="0"/>
-              <a:t>5/19/26</a:t>
+              <a:t>5/20/26</a:t>
             </a:fld>
             <a:endParaRPr lang="en-US"/>
           </a:p>
@@ -479,7 +480,7 @@
           <a:p>
             <a:fld id="{5BCAD085-E8A6-8845-BD4E-CB4CCA059FC4}" type="datetimeFigureOut">
               <a:rPr lang="en-US" smtClean="0"/>
-              <a:t>5/19/26</a:t>
+              <a:t>5/20/26</a:t>
             </a:fld>
             <a:endParaRPr lang="en-US"/>
           </a:p>
@@ -657,7 +658,7 @@
           <a:p>
             <a:fld id="{5BCAD085-E8A6-8845-BD4E-CB4CCA059FC4}" type="datetimeFigureOut">
               <a:rPr lang="en-US" smtClean="0"/>
-              <a:t>5/19/26</a:t>
+              <a:t>5/20/26</a:t>
             </a:fld>
             <a:endParaRPr lang="en-US"/>
           </a:p>
@@ -825,7 +826,7 @@
           <a:p>
             <a:fld id="{5BCAD085-E8A6-8845-BD4E-CB4CCA059FC4}" type="datetimeFigureOut">
               <a:rPr lang="en-US" smtClean="0"/>
-              <a:t>5/19/26</a:t>
+              <a:t>5/20/26</a:t>
             </a:fld>
             <a:endParaRPr lang="en-US"/>
           </a:p>
@@ -1070,7 +1071,7 @@
           <a:p>
             <a:fld id="{5BCAD085-E8A6-8845-BD4E-CB4CCA059FC4}" type="datetimeFigureOut">
               <a:rPr lang="en-US" smtClean="0"/>
-              <a:t>5/19/26</a:t>
+              <a:t>5/20/26</a:t>
             </a:fld>
             <a:endParaRPr lang="en-US"/>
           </a:p>
@@ -1355,7 +1356,7 @@
           <a:p>
             <a:fld id="{5BCAD085-E8A6-8845-BD4E-CB4CCA059FC4}" type="datetimeFigureOut">
               <a:rPr lang="en-US" smtClean="0"/>
-              <a:t>5/19/26</a:t>
+              <a:t>5/20/26</a:t>
             </a:fld>
             <a:endParaRPr lang="en-US"/>
           </a:p>
@@ -1774,7 +1775,7 @@
           <a:p>
             <a:fld id="{5BCAD085-E8A6-8845-BD4E-CB4CCA059FC4}" type="datetimeFigureOut">
               <a:rPr lang="en-US" smtClean="0"/>
-              <a:t>5/19/26</a:t>
+              <a:t>5/20/26</a:t>
             </a:fld>
             <a:endParaRPr lang="en-US"/>
           </a:p>
@@ -1891,7 +1892,7 @@
           <a:p>
             <a:fld id="{5BCAD085-E8A6-8845-BD4E-CB4CCA059FC4}" type="datetimeFigureOut">
               <a:rPr lang="en-US" smtClean="0"/>
-              <a:t>5/19/26</a:t>
+              <a:t>5/20/26</a:t>
             </a:fld>
             <a:endParaRPr lang="en-US"/>
           </a:p>
@@ -1986,7 +1987,7 @@
           <a:p>
             <a:fld id="{5BCAD085-E8A6-8845-BD4E-CB4CCA059FC4}" type="datetimeFigureOut">
               <a:rPr lang="en-US" smtClean="0"/>
-              <a:t>5/19/26</a:t>
+              <a:t>5/20/26</a:t>
             </a:fld>
             <a:endParaRPr lang="en-US"/>
           </a:p>
@@ -2261,7 +2262,7 @@
           <a:p>
             <a:fld id="{5BCAD085-E8A6-8845-BD4E-CB4CCA059FC4}" type="datetimeFigureOut">
               <a:rPr lang="en-US" smtClean="0"/>
-              <a:t>5/19/26</a:t>
+              <a:t>5/20/26</a:t>
             </a:fld>
             <a:endParaRPr lang="en-US"/>
           </a:p>
@@ -2513,7 +2514,7 @@
           <a:p>
             <a:fld id="{5BCAD085-E8A6-8845-BD4E-CB4CCA059FC4}" type="datetimeFigureOut">
               <a:rPr lang="en-US" smtClean="0"/>
-              <a:t>5/19/26</a:t>
+              <a:t>5/20/26</a:t>
             </a:fld>
             <a:endParaRPr lang="en-US"/>
           </a:p>
@@ -2724,7 +2725,7 @@
           <a:p>
             <a:fld id="{5BCAD085-E8A6-8845-BD4E-CB4CCA059FC4}" type="datetimeFigureOut">
               <a:rPr lang="en-US" smtClean="0"/>
-              <a:t>5/19/26</a:t>
+              <a:t>5/20/26</a:t>
             </a:fld>
             <a:endParaRPr lang="en-US"/>
           </a:p>
@@ -3180,8 +3181,10 @@
               </a:defRPr>
             </a:pPr>
             <a:r>
-              <a:t>K8ssandra on EKS</a:t>
-            </a:r>
+              <a:rPr lang="en-US" dirty="0"/>
+              <a:t>Control C* Con Claude Code</a:t>
+            </a:r>
+            <a:endParaRPr dirty="0"/>
           </a:p>
         </p:txBody>
       </p:sp>
@@ -3214,8 +3217,10 @@
               </a:defRPr>
             </a:pPr>
             <a:r>
-              <a:t>Reference Architecture</a:t>
-            </a:r>
+              <a:rPr lang="en-US" dirty="0"/>
+              <a:t>MCP + Skills = Awesome</a:t>
+            </a:r>
+            <a:endParaRPr dirty="0"/>
           </a:p>
         </p:txBody>
       </p:sp>
@@ -4389,6 +4394,349 @@
 </p:sld>
 </file>
 
+<file path=ppt/slides/slide11.xml><?xml version="1.0" encoding="utf-8"?>
+<p:sld xmlns:a="http://schemas.openxmlformats.org/drawingml/2006/main" xmlns:r="http://schemas.openxmlformats.org/officeDocument/2006/relationships" xmlns:p="http://schemas.openxmlformats.org/presentationml/2006/main">
+  <p:cSld>
+    <p:bg>
+      <p:bgPr>
+        <a:solidFill>
+          <a:srgbClr val="161616"/>
+        </a:solidFill>
+        <a:effectLst/>
+      </p:bgPr>
+    </p:bg>
+    <p:spTree>
+      <p:nvGrpSpPr>
+        <p:cNvPr id="1" name="">
+          <a:extLst>
+            <a:ext uri="{FF2B5EF4-FFF2-40B4-BE49-F238E27FC236}">
+              <a16:creationId xmlns:a16="http://schemas.microsoft.com/office/drawing/2014/main" id="{A689CFC8-A3A8-916D-A336-952955F25725}"/>
+            </a:ext>
+          </a:extLst>
+        </p:cNvPr>
+        <p:cNvGrpSpPr/>
+        <p:nvPr/>
+      </p:nvGrpSpPr>
+      <p:grpSpPr>
+        <a:xfrm>
+          <a:off x="0" y="0"/>
+          <a:ext cx="0" cy="0"/>
+          <a:chOff x="0" y="0"/>
+          <a:chExt cx="0" cy="0"/>
+        </a:xfrm>
+      </p:grpSpPr>
+      <p:sp>
+        <p:nvSpPr>
+          <p:cNvPr id="2" name="Title Bar">
+            <a:extLst>
+              <a:ext uri="{FF2B5EF4-FFF2-40B4-BE49-F238E27FC236}">
+                <a16:creationId xmlns:a16="http://schemas.microsoft.com/office/drawing/2014/main" id="{71B3FEB2-270B-AECA-2F61-4B8159B6A1D0}"/>
+              </a:ext>
+            </a:extLst>
+          </p:cNvPr>
+          <p:cNvSpPr/>
+          <p:nvPr/>
+        </p:nvSpPr>
+        <p:spPr>
+          <a:xfrm>
+            <a:off x="731520" y="365760"/>
+            <a:ext cx="54864" cy="411480"/>
+          </a:xfrm>
+          <a:prstGeom prst="rect">
+            <a:avLst/>
+          </a:prstGeom>
+          <a:solidFill>
+            <a:srgbClr val="0F62FE"/>
+          </a:solidFill>
+          <a:ln>
+            <a:noFill/>
+          </a:ln>
+        </p:spPr>
+        <p:style>
+          <a:lnRef idx="1">
+            <a:schemeClr val="accent1"/>
+          </a:lnRef>
+          <a:fillRef idx="3">
+            <a:schemeClr val="accent1"/>
+          </a:fillRef>
+          <a:effectRef idx="2">
+            <a:schemeClr val="accent1"/>
+          </a:effectRef>
+          <a:fontRef idx="minor">
+            <a:schemeClr val="lt1"/>
+          </a:fontRef>
+        </p:style>
+        <p:txBody>
+          <a:bodyPr rtlCol="0" anchor="ctr"/>
+          <a:lstStyle/>
+          <a:p>
+            <a:pPr marL="0" marR="0" lvl="0" indent="0" algn="ctr" defTabSz="457200" rtl="0" eaLnBrk="1" fontAlgn="auto" latinLnBrk="0" hangingPunct="1">
+              <a:lnSpc>
+                <a:spcPct val="100000"/>
+              </a:lnSpc>
+              <a:spcBef>
+                <a:spcPts val="0"/>
+              </a:spcBef>
+              <a:spcAft>
+                <a:spcPts val="0"/>
+              </a:spcAft>
+              <a:buClrTx/>
+              <a:buSzTx/>
+              <a:buFontTx/>
+              <a:buNone/>
+              <a:tabLst/>
+              <a:defRPr/>
+            </a:pPr>
+            <a:endParaRPr kumimoji="0" sz="2800" b="0" i="0" u="none" strike="noStrike" kern="1200" cap="none" spc="0" normalizeH="0" baseline="0" noProof="0">
+              <a:ln>
+                <a:noFill/>
+              </a:ln>
+              <a:solidFill>
+                <a:prstClr val="white"/>
+              </a:solidFill>
+              <a:effectLst/>
+              <a:uLnTx/>
+              <a:uFillTx/>
+              <a:latin typeface="Calibri"/>
+              <a:ea typeface="+mn-ea"/>
+              <a:cs typeface="+mn-cs"/>
+            </a:endParaRPr>
+          </a:p>
+        </p:txBody>
+      </p:sp>
+      <p:sp>
+        <p:nvSpPr>
+          <p:cNvPr id="3" name="Title">
+            <a:extLst>
+              <a:ext uri="{FF2B5EF4-FFF2-40B4-BE49-F238E27FC236}">
+                <a16:creationId xmlns:a16="http://schemas.microsoft.com/office/drawing/2014/main" id="{E6B1F904-D0A5-1949-02B9-57928CCC86EC}"/>
+              </a:ext>
+            </a:extLst>
+          </p:cNvPr>
+          <p:cNvSpPr txBox="1"/>
+          <p:nvPr/>
+        </p:nvSpPr>
+        <p:spPr>
+          <a:xfrm>
+            <a:off x="960120" y="365760"/>
+            <a:ext cx="10000000" cy="502920"/>
+          </a:xfrm>
+          <a:prstGeom prst="rect">
+            <a:avLst/>
+          </a:prstGeom>
+          <a:noFill/>
+        </p:spPr>
+        <p:txBody>
+          <a:bodyPr wrap="square" lIns="0" tIns="0"/>
+          <a:lstStyle/>
+          <a:p>
+            <a:pPr marL="0" marR="0" lvl="0" indent="0" algn="l" defTabSz="457200" rtl="0" eaLnBrk="1" fontAlgn="auto" latinLnBrk="0" hangingPunct="1">
+              <a:lnSpc>
+                <a:spcPct val="100000"/>
+              </a:lnSpc>
+              <a:spcBef>
+                <a:spcPts val="0"/>
+              </a:spcBef>
+              <a:spcAft>
+                <a:spcPts val="0"/>
+              </a:spcAft>
+              <a:buClrTx/>
+              <a:buSzTx/>
+              <a:buFontTx/>
+              <a:buNone/>
+              <a:tabLst/>
+              <a:defRPr sz="2800" b="1">
+                <a:solidFill>
+                  <a:srgbClr val="FFFFFF"/>
+                </a:solidFill>
+                <a:latin typeface="Calibri"/>
+              </a:defRPr>
+            </a:pPr>
+            <a:r>
+              <a:rPr kumimoji="0" lang="en-US" sz="2800" b="1" i="0" u="none" strike="noStrike" kern="1200" cap="none" spc="0" normalizeH="0" baseline="0" noProof="0" dirty="0">
+                <a:ln>
+                  <a:noFill/>
+                </a:ln>
+                <a:solidFill>
+                  <a:srgbClr val="FFFFFF"/>
+                </a:solidFill>
+                <a:effectLst/>
+                <a:uLnTx/>
+                <a:uFillTx/>
+                <a:latin typeface="Calibri"/>
+                <a:ea typeface="+mn-ea"/>
+                <a:cs typeface="+mn-cs"/>
+              </a:rPr>
+              <a:t>Workshop Repo</a:t>
+            </a:r>
+            <a:endParaRPr kumimoji="0" sz="2800" b="1" i="0" u="none" strike="noStrike" kern="1200" cap="none" spc="0" normalizeH="0" baseline="0" noProof="0" dirty="0">
+              <a:ln>
+                <a:noFill/>
+              </a:ln>
+              <a:solidFill>
+                <a:srgbClr val="FFFFFF"/>
+              </a:solidFill>
+              <a:effectLst/>
+              <a:uLnTx/>
+              <a:uFillTx/>
+              <a:latin typeface="Calibri"/>
+              <a:ea typeface="+mn-ea"/>
+              <a:cs typeface="+mn-cs"/>
+            </a:endParaRPr>
+          </a:p>
+        </p:txBody>
+      </p:sp>
+      <p:sp>
+        <p:nvSpPr>
+          <p:cNvPr id="40" name="Footer">
+            <a:extLst>
+              <a:ext uri="{FF2B5EF4-FFF2-40B4-BE49-F238E27FC236}">
+                <a16:creationId xmlns:a16="http://schemas.microsoft.com/office/drawing/2014/main" id="{63B42C49-4F67-B960-894D-B774613D0BC8}"/>
+              </a:ext>
+            </a:extLst>
+          </p:cNvPr>
+          <p:cNvSpPr txBox="1"/>
+          <p:nvPr/>
+        </p:nvSpPr>
+        <p:spPr>
+          <a:xfrm>
+            <a:off x="3952262" y="5685060"/>
+            <a:ext cx="4287473" cy="411480"/>
+          </a:xfrm>
+          <a:prstGeom prst="rect">
+            <a:avLst/>
+          </a:prstGeom>
+          <a:noFill/>
+        </p:spPr>
+        <p:txBody>
+          <a:bodyPr wrap="square" lIns="0" tIns="0"/>
+          <a:lstStyle/>
+          <a:p>
+            <a:pPr marL="0" marR="0" lvl="0" indent="0" algn="ctr" defTabSz="457200" rtl="0" eaLnBrk="1" fontAlgn="auto" latinLnBrk="0" hangingPunct="1">
+              <a:lnSpc>
+                <a:spcPct val="100000"/>
+              </a:lnSpc>
+              <a:spcBef>
+                <a:spcPts val="0"/>
+              </a:spcBef>
+              <a:spcAft>
+                <a:spcPts val="0"/>
+              </a:spcAft>
+              <a:buClrTx/>
+              <a:buSzTx/>
+              <a:buFontTx/>
+              <a:buNone/>
+              <a:tabLst/>
+              <a:defRPr sz="1400" b="1" i="1">
+                <a:solidFill>
+                  <a:srgbClr val="78A9FF"/>
+                </a:solidFill>
+                <a:latin typeface="Calibri"/>
+              </a:defRPr>
+            </a:pPr>
+            <a:r>
+              <a:rPr lang="en-US" sz="2400" b="1" dirty="0" err="1">
+                <a:solidFill>
+                  <a:srgbClr val="78A9FF"/>
+                </a:solidFill>
+                <a:latin typeface="Calibri"/>
+              </a:rPr>
+              <a:t>i</a:t>
+            </a:r>
+            <a:r>
+              <a:rPr kumimoji="0" lang="en-US" sz="2400" b="1" u="none" strike="noStrike" kern="1200" cap="none" spc="0" normalizeH="0" baseline="0" noProof="0" dirty="0" err="1">
+                <a:ln>
+                  <a:noFill/>
+                </a:ln>
+                <a:solidFill>
+                  <a:srgbClr val="78A9FF"/>
+                </a:solidFill>
+                <a:effectLst/>
+                <a:uLnTx/>
+                <a:uFillTx/>
+                <a:latin typeface="Calibri"/>
+                <a:ea typeface="+mn-ea"/>
+                <a:cs typeface="+mn-cs"/>
+              </a:rPr>
+              <a:t>bm.biz</a:t>
+            </a:r>
+            <a:r>
+              <a:rPr kumimoji="0" lang="en-US" sz="2400" b="1" u="none" strike="noStrike" kern="1200" cap="none" spc="0" normalizeH="0" baseline="0" noProof="0" dirty="0">
+                <a:ln>
+                  <a:noFill/>
+                </a:ln>
+                <a:solidFill>
+                  <a:srgbClr val="78A9FF"/>
+                </a:solidFill>
+                <a:effectLst/>
+                <a:uLnTx/>
+                <a:uFillTx/>
+                <a:latin typeface="Calibri"/>
+                <a:ea typeface="+mn-ea"/>
+                <a:cs typeface="+mn-cs"/>
+              </a:rPr>
+              <a:t>/k8ssandra-claude-repo</a:t>
+            </a:r>
+            <a:endParaRPr kumimoji="0" sz="2400" b="1" u="none" strike="noStrike" kern="1200" cap="none" spc="0" normalizeH="0" baseline="0" noProof="0" dirty="0">
+              <a:ln>
+                <a:noFill/>
+              </a:ln>
+              <a:solidFill>
+                <a:srgbClr val="78A9FF"/>
+              </a:solidFill>
+              <a:effectLst/>
+              <a:uLnTx/>
+              <a:uFillTx/>
+              <a:latin typeface="Calibri"/>
+              <a:ea typeface="+mn-ea"/>
+              <a:cs typeface="+mn-cs"/>
+            </a:endParaRPr>
+          </a:p>
+        </p:txBody>
+      </p:sp>
+      <p:pic>
+        <p:nvPicPr>
+          <p:cNvPr id="7" name="Picture 6">
+            <a:extLst>
+              <a:ext uri="{FF2B5EF4-FFF2-40B4-BE49-F238E27FC236}">
+                <a16:creationId xmlns:a16="http://schemas.microsoft.com/office/drawing/2014/main" id="{5EC01F33-6E8B-BE1A-C94F-F59A2FBDEA7D}"/>
+              </a:ext>
+            </a:extLst>
+          </p:cNvPr>
+          <p:cNvPicPr>
+            <a:picLocks noChangeAspect="1"/>
+          </p:cNvPicPr>
+          <p:nvPr/>
+        </p:nvPicPr>
+        <p:blipFill>
+          <a:blip r:embed="rId2"/>
+          <a:stretch>
+            <a:fillRect/>
+          </a:stretch>
+        </p:blipFill>
+        <p:spPr>
+          <a:xfrm>
+            <a:off x="4182951" y="1515951"/>
+            <a:ext cx="3826097" cy="3826097"/>
+          </a:xfrm>
+          <a:prstGeom prst="rect">
+            <a:avLst/>
+          </a:prstGeom>
+        </p:spPr>
+      </p:pic>
+    </p:spTree>
+    <p:extLst>
+      <p:ext uri="{BB962C8B-B14F-4D97-AF65-F5344CB8AC3E}">
+        <p14:creationId xmlns:p14="http://schemas.microsoft.com/office/powerpoint/2010/main" val="2306626734"/>
+      </p:ext>
+    </p:extLst>
+  </p:cSld>
+  <p:clrMapOvr>
+    <a:masterClrMapping/>
+  </p:clrMapOvr>
+</p:sld>
+</file>
+
 <file path=ppt/slides/slide2.xml><?xml version="1.0" encoding="utf-8"?>
 <p:sld xmlns:a="http://schemas.openxmlformats.org/drawingml/2006/main" xmlns:r="http://schemas.openxmlformats.org/officeDocument/2006/relationships" xmlns:p="http://schemas.openxmlformats.org/presentationml/2006/main">
   <p:cSld>
@@ -4743,7 +5091,7 @@
         </p:nvSpPr>
         <p:spPr>
           <a:xfrm>
-            <a:off x="6151004" y="1503226"/>
+            <a:off x="6214802" y="1503226"/>
             <a:ext cx="2500000" cy="228600"/>
           </a:xfrm>
           <a:prstGeom prst="rect">
@@ -4778,7 +5126,7 @@
         </p:nvSpPr>
         <p:spPr>
           <a:xfrm>
-            <a:off x="6214682" y="1800000"/>
+            <a:off x="6278480" y="1800000"/>
             <a:ext cx="2500000" cy="2700000"/>
           </a:xfrm>
           <a:prstGeom prst="rect">
@@ -4917,7 +5265,7 @@
         </p:nvSpPr>
         <p:spPr>
           <a:xfrm>
-            <a:off x="6214682" y="4550000"/>
+            <a:off x="6278480" y="4550000"/>
             <a:ext cx="2500000" cy="274320"/>
           </a:xfrm>
           <a:prstGeom prst="rect">
@@ -4952,7 +5300,7 @@
         </p:nvSpPr>
         <p:spPr>
           <a:xfrm>
-            <a:off x="3285725" y="1500000"/>
+            <a:off x="3392055" y="1500000"/>
             <a:ext cx="2500000" cy="228600"/>
           </a:xfrm>
           <a:prstGeom prst="rect">
@@ -4987,7 +5335,7 @@
         </p:nvSpPr>
         <p:spPr>
           <a:xfrm>
-            <a:off x="3285725" y="1800000"/>
+            <a:off x="3392055" y="1800000"/>
             <a:ext cx="2500000" cy="2700000"/>
           </a:xfrm>
           <a:prstGeom prst="rect">
@@ -5126,7 +5474,7 @@
         </p:nvSpPr>
         <p:spPr>
           <a:xfrm>
-            <a:off x="3285725" y="4550000"/>
+            <a:off x="3392055" y="4550000"/>
             <a:ext cx="2500000" cy="274320"/>
           </a:xfrm>
           <a:prstGeom prst="rect">
@@ -5161,7 +5509,7 @@
         </p:nvSpPr>
         <p:spPr>
           <a:xfrm>
-            <a:off x="9143640" y="1500000"/>
+            <a:off x="9207438" y="1500000"/>
             <a:ext cx="2500000" cy="228600"/>
           </a:xfrm>
           <a:prstGeom prst="rect">
@@ -5196,7 +5544,7 @@
         </p:nvSpPr>
         <p:spPr>
           <a:xfrm>
-            <a:off x="9143640" y="1800000"/>
+            <a:off x="9207438" y="1800000"/>
             <a:ext cx="2500000" cy="2700000"/>
           </a:xfrm>
           <a:prstGeom prst="rect">
@@ -5335,7 +5683,7 @@
         </p:nvSpPr>
         <p:spPr>
           <a:xfrm>
-            <a:off x="9143640" y="4550000"/>
+            <a:off x="9207438" y="4550000"/>
             <a:ext cx="2500000" cy="274320"/>
           </a:xfrm>
           <a:prstGeom prst="rect">
@@ -5370,7 +5718,7 @@
         </p:nvSpPr>
         <p:spPr>
           <a:xfrm>
-            <a:off x="3066928" y="3131712"/>
+            <a:off x="3120093" y="3131712"/>
             <a:ext cx="118872" cy="36576"/>
           </a:xfrm>
           <a:prstGeom prst="rect">
@@ -5414,7 +5762,7 @@
         </p:nvSpPr>
         <p:spPr>
           <a:xfrm rot="5400000">
-            <a:off x="3176276" y="3095136"/>
+            <a:off x="3240074" y="3095136"/>
             <a:ext cx="109728" cy="109728"/>
           </a:xfrm>
           <a:prstGeom prst="triangle">
@@ -5458,7 +5806,7 @@
         </p:nvSpPr>
         <p:spPr>
           <a:xfrm>
-            <a:off x="5922125" y="3138881"/>
+            <a:off x="5985923" y="3138881"/>
             <a:ext cx="118872" cy="36576"/>
           </a:xfrm>
           <a:prstGeom prst="rect">
@@ -5502,7 +5850,7 @@
         </p:nvSpPr>
         <p:spPr>
           <a:xfrm rot="5400000">
-            <a:off x="6041276" y="3095136"/>
+            <a:off x="6105074" y="3095136"/>
             <a:ext cx="109728" cy="109728"/>
           </a:xfrm>
           <a:prstGeom prst="triangle">
@@ -5546,7 +5894,7 @@
         </p:nvSpPr>
         <p:spPr>
           <a:xfrm>
-            <a:off x="8796928" y="3131712"/>
+            <a:off x="8860726" y="3131712"/>
             <a:ext cx="118872" cy="36576"/>
           </a:xfrm>
           <a:prstGeom prst="rect">
@@ -5590,7 +5938,7 @@
         </p:nvSpPr>
         <p:spPr>
           <a:xfrm rot="5400000">
-            <a:off x="8906276" y="3095136"/>
+            <a:off x="8970074" y="3095136"/>
             <a:ext cx="109728" cy="109728"/>
           </a:xfrm>
           <a:prstGeom prst="triangle">
@@ -9412,7 +9760,7 @@
 </file>
 
 <file path=ppt/slides/slide5.xml><?xml version="1.0" encoding="utf-8"?>
-<p:sld xmlns:a="http://schemas.openxmlformats.org/drawingml/2006/main" xmlns:r="http://schemas.openxmlformats.org/officeDocument/2006/relationships" xmlns:p="http://schemas.openxmlformats.org/presentationml/2006/main">
+<p:sld xmlns:a="http://schemas.openxmlformats.org/drawingml/2006/main" xmlns:r="http://schemas.openxmlformats.org/officeDocument/2006/relationships" xmlns:p="http://schemas.openxmlformats.org/presentationml/2006/main" show="0">
   <p:cSld>
     <p:bg>
       <p:bgPr>
@@ -12093,7 +12441,7 @@
 </file>
 
 <file path=ppt/slides/slide6.xml><?xml version="1.0" encoding="utf-8"?>
-<p:sld xmlns:a="http://schemas.openxmlformats.org/drawingml/2006/main" xmlns:r="http://schemas.openxmlformats.org/officeDocument/2006/relationships" xmlns:p="http://schemas.openxmlformats.org/presentationml/2006/main">
+<p:sld xmlns:a="http://schemas.openxmlformats.org/drawingml/2006/main" xmlns:r="http://schemas.openxmlformats.org/officeDocument/2006/relationships" xmlns:p="http://schemas.openxmlformats.org/presentationml/2006/main" show="0">
   <p:cSld>
     <p:bg>
       <p:bgPr>
@@ -14470,7 +14818,7 @@
 </file>
 
 <file path=ppt/slides/slide7.xml><?xml version="1.0" encoding="utf-8"?>
-<p:sld xmlns:a="http://schemas.openxmlformats.org/drawingml/2006/main" xmlns:r="http://schemas.openxmlformats.org/officeDocument/2006/relationships" xmlns:p="http://schemas.openxmlformats.org/presentationml/2006/main">
+<p:sld xmlns:a="http://schemas.openxmlformats.org/drawingml/2006/main" xmlns:r="http://schemas.openxmlformats.org/officeDocument/2006/relationships" xmlns:p="http://schemas.openxmlformats.org/presentationml/2006/main" show="0">
   <p:cSld>
     <p:bg>
       <p:bgPr>

</xml_diff>

<commit_message>
Revise the reference-architecture deck
- Slide 3: reworded "What k8ssandra Is (and Isn't)"
- Slide 4: "running database ecosystem" in place of "running suite"
- Slide 5: CR excerpt is ~100 lines of YAML, not ~150
- Slide 16: retitled "Two Skills + an Agent, Three Lenses"
- Removed the closing "Workshop Repo" link slide (18 -> 17 slides)

Co-Authored-By: Claude Opus 5.5 (1M context) <noreply@anthropic.com>
</commit_message>
<xml_diff>
--- a/k8ssandra-reference-architecture.pptx
+++ b/k8ssandra-reference-architecture.pptx
@@ -22,7 +22,6 @@
     <p:sldId id="262" r:id="rId16"/>
     <p:sldId id="264" r:id="rId17"/>
     <p:sldId id="273" r:id="rId18"/>
-    <p:sldId id="266" r:id="rId19"/>
   </p:sldIdLst>
   <p:sldSz cx="12192000" cy="6858000"/>
   <p:notesSz cx="6858000" cy="9144000"/>
@@ -3852,7 +3851,7 @@
               </a:defRPr>
             </a:pPr>
             <a:r>
-              <a:rPr sz="1200"/>
+              <a:rPr sz="1200" dirty="0"/>
               <a:t>Throughput  ·  p50/p99 read + write latency</a:t>
             </a:r>
           </a:p>
@@ -3873,8 +3872,16 @@
               </a:defRPr>
             </a:pPr>
             <a:r>
-              <a:rPr sz="1200"/>
-              <a:t>Pending compactions  ·  live sstable count</a:t>
+              <a:rPr sz="1200" dirty="0"/>
+              <a:t>Pending compactions  ·  live </a:t>
+            </a:r>
+            <a:r>
+              <a:rPr sz="1200" dirty="0" err="1"/>
+              <a:t>sstable</a:t>
+            </a:r>
+            <a:r>
+              <a:rPr sz="1200" dirty="0"/>
+              <a:t> count</a:t>
             </a:r>
           </a:p>
           <a:p>
@@ -3894,7 +3901,7 @@
               </a:defRPr>
             </a:pPr>
             <a:r>
-              <a:rPr sz="1200"/>
+              <a:rPr sz="1200" dirty="0"/>
               <a:t>Per-pod CPU (Cassandra) + worker node CPU (Thanos)</a:t>
             </a:r>
           </a:p>
@@ -3915,17 +3922,14 @@
               </a:defRPr>
             </a:pPr>
             <a:r>
-              <a:rPr sz="1200" b="1"/>
+              <a:rPr sz="1200" b="1" dirty="0"/>
               <a:t>CFS throttling %</a:t>
             </a:r>
-            <a:r>
-              <a:rPr sz="1200">
-                <a:solidFill>
-                  <a:srgbClr val="C6C6C6"/>
-                </a:solidFill>
-              </a:rPr>
-              <a:t>  (the Part 8 finding, live)</a:t>
-            </a:r>
+            <a:endParaRPr lang="en-US" sz="1200" dirty="0">
+              <a:solidFill>
+                <a:srgbClr val="C6C6C6"/>
+              </a:solidFill>
+            </a:endParaRPr>
           </a:p>
           <a:p>
             <a:pPr marL="228600" indent="-228600" algn="l">
@@ -3944,17 +3948,14 @@
               </a:defRPr>
             </a:pPr>
             <a:r>
-              <a:rPr sz="1200"/>
-              <a:t>PVC used %  ·  </a:t>
-            </a:r>
-            <a:r>
-              <a:rPr sz="1200" b="1">
-                <a:solidFill>
-                  <a:srgbClr val="F1C21B"/>
-                </a:solidFill>
-              </a:rPr>
-              <a:t>projected hours until PVC full</a:t>
-            </a:r>
+              <a:rPr lang="en-US" sz="1200" dirty="0"/>
+              <a:t>PVC used %  ·</a:t>
+            </a:r>
+            <a:endParaRPr lang="en-US" sz="1200" b="1" dirty="0">
+              <a:solidFill>
+                <a:srgbClr val="F1C21B"/>
+              </a:solidFill>
+            </a:endParaRPr>
           </a:p>
           <a:p>
             <a:pPr marL="228600" indent="-228600" algn="l">
@@ -3973,8 +3974,8 @@
               </a:defRPr>
             </a:pPr>
             <a:r>
-              <a:rPr sz="1200"/>
-              <a:t>Reaper repair progress  ·  segments/hour</a:t>
+              <a:rPr sz="1200" dirty="0"/>
+              <a:t>GC time  ·  heap  ·  dropped messages  ·  hints</a:t>
             </a:r>
           </a:p>
         </p:txBody>
@@ -4019,7 +4020,7 @@
             </a:pPr>
             <a:r>
               <a:rPr sz="1200" b="1"/>
-              <a:t>Gotcha: published dashboards are empty</a:t>
+              <a:t>Gotcha: the classic dashboards are empty</a:t>
             </a:r>
           </a:p>
           <a:p>
@@ -4036,7 +4037,7 @@
             </a:pPr>
             <a:r>
               <a:rPr sz="1050"/>
-              <a:t>They target the deprecated MCAC endpoint (collectd_mcac_*).</a:t>
+              <a:t>They target deprecated MCAC (collectd_mcac_*) — use the new-endpoint set.</a:t>
             </a:r>
           </a:p>
           <a:p>
@@ -4088,7 +4089,7 @@
             </a:pPr>
             <a:r>
               <a:rPr i="1"/>
-              <a:t>kubectl get servicemonitor -n default  →  demo-dc1-cass-servicemonitor  ·  demo-dc1-reaper-servicemonitor</a:t>
+              <a:t>kubectl get servicemonitor -n default  →  demo-dc1-cass-servicemonitor  ·  demo-dc1-reaper-reaper-servicemonitor</a:t>
             </a:r>
           </a:p>
         </p:txBody>
@@ -4305,7 +4306,7 @@
               </a:defRPr>
             </a:pPr>
             <a:r>
-              <a:rPr sz="1300" b="1"/>
+              <a:rPr sz="1300" b="1" dirty="0"/>
               <a:t>Replicas drift</a:t>
             </a:r>
           </a:p>
@@ -4326,7 +4327,7 @@
               </a:defRPr>
             </a:pPr>
             <a:r>
-              <a:rPr sz="1150"/>
+              <a:rPr sz="1150" dirty="0"/>
               <a:t>Writes fail; hints expire; nodes miss mutations while down.</a:t>
             </a:r>
           </a:p>
@@ -4350,7 +4351,7 @@
               </a:defRPr>
             </a:pPr>
             <a:r>
-              <a:rPr sz="1300" b="1"/>
+              <a:rPr sz="1300" b="1" dirty="0"/>
               <a:t>Tombstones expire</a:t>
             </a:r>
           </a:p>
@@ -4371,8 +4372,16 @@
               </a:defRPr>
             </a:pPr>
             <a:r>
-              <a:rPr sz="1150"/>
-              <a:t>After gc_grace_seconds, tombstones are collected.</a:t>
+              <a:rPr sz="1150" dirty="0"/>
+              <a:t>After </a:t>
+            </a:r>
+            <a:r>
+              <a:rPr sz="1150" dirty="0" err="1"/>
+              <a:t>gc_grace_seconds</a:t>
+            </a:r>
+            <a:r>
+              <a:rPr sz="1150" dirty="0"/>
+              <a:t>, tombstones are collected.</a:t>
             </a:r>
           </a:p>
           <a:p>
@@ -4395,7 +4404,7 @@
               </a:defRPr>
             </a:pPr>
             <a:r>
-              <a:rPr sz="1300" b="1"/>
+              <a:rPr sz="1300" b="1" dirty="0"/>
               <a:t>Deleted rows return</a:t>
             </a:r>
           </a:p>
@@ -4416,7 +4425,7 @@
               </a:defRPr>
             </a:pPr>
             <a:r>
-              <a:rPr sz="1150"/>
+              <a:rPr sz="1150" dirty="0"/>
               <a:t>If a delete never propagated, and the tombstone is gone, a replica that never heard about the delete resurrects the row.</a:t>
             </a:r>
           </a:p>
@@ -4434,7 +4443,7 @@
               </a:defRPr>
             </a:pPr>
             <a:r>
-              <a:rPr sz="1200" b="1" i="1"/>
+              <a:rPr sz="1200" b="1" i="1" dirty="0"/>
               <a:t>→  Zombie data.</a:t>
             </a:r>
           </a:p>
@@ -5113,7 +5122,7 @@
             </a:pPr>
             <a:r>
               <a:rPr sz="1100"/>
-              <a:t>  demo-talk-backup  SUCCESS     6/6</a:t>
+              <a:t>  demo-talk-backup  SUCCESS     3/3</a:t>
             </a:r>
           </a:p>
         </p:txBody>
@@ -5218,7 +5227,7 @@
             </a:pPr>
             <a:r>
               <a:rPr sz="1200"/>
-              <a:t>47.84 GB  ·  4,732 files  ·  6/6 nodes  ·  8m38s</a:t>
+              <a:t>3 nodes: ~4–5 min  ·  6 nodes: 47.84 GB, 4,732 files, 8m38s</a:t>
             </a:r>
           </a:p>
           <a:p>
@@ -6056,7 +6065,7 @@
             </a:pPr>
             <a:r>
               <a:rPr sz="1050"/>
-              <a:t>Zero-Copy streaming, RF=3 held</a:t>
+              <a:t>Streamed under load, RF=3 held</a:t>
             </a:r>
           </a:p>
         </p:txBody>
@@ -7325,7 +7334,7 @@
             </a:pPr>
             <a:r>
               <a:rPr sz="1050"/>
-              <a:t>get_table_latency  →  3 rows, key metrics</a:t>
+              <a:t>query_all_nodes  →  one row per node</a:t>
             </a:r>
           </a:p>
           <a:p>
@@ -9514,7 +9523,7 @@
               </a:defRPr>
             </a:pPr>
             <a:r>
-              <a:t>Three Cassandra Skills, Three Lenses</a:t>
+              <a:t>Two Skills + an Agent, Three Lenses</a:t>
             </a:r>
           </a:p>
         </p:txBody>
@@ -9976,7 +9985,7 @@
             </a:pPr>
             <a:r>
               <a:rPr sz="1000" i="1"/>
-              <a:t>“key_cache_size_in_mb: 0 in operator default. Table requests caching: ALL — silently ignored. Fix to 100. Expected: 92k → 110-120k ops/sec.”</a:t>
+              <a:t>“key_cache_size: 0 in operator default. Table requests caching: ALL — silently ignored. Fix to 100MiB. Expected: 92k → 110-120k ops/sec.”</a:t>
             </a:r>
           </a:p>
         </p:txBody>
@@ -10069,8 +10078,8 @@
               </a:defRPr>
             </a:pPr>
             <a:r>
-              <a:rPr sz="2400"/>
-              <a:t>/expert</a:t>
+              <a:rPr sz="1800"/>
+              <a:t>@cassandra-expert</a:t>
             </a:r>
           </a:p>
           <a:p>
@@ -10496,7 +10505,7 @@
             </a:pPr>
             <a:r>
               <a:rPr sz="1100"/>
-              <a:t>CFS periods throttled       peaks at 6.7 %</a:t>
+              <a:t>CFS periods throttled       peaks at 6.7 %  (50/50 run)</a:t>
             </a:r>
           </a:p>
           <a:p>
@@ -11033,349 +11042,6 @@
         </p:txBody>
       </p:sp>
     </p:spTree>
-  </p:cSld>
-  <p:clrMapOvr>
-    <a:masterClrMapping/>
-  </p:clrMapOvr>
-</p:sld>
-</file>
-
-<file path=ppt/slides/slide18.xml><?xml version="1.0" encoding="utf-8"?>
-<p:sld xmlns:a="http://schemas.openxmlformats.org/drawingml/2006/main" xmlns:r="http://schemas.openxmlformats.org/officeDocument/2006/relationships" xmlns:p="http://schemas.openxmlformats.org/presentationml/2006/main">
-  <p:cSld>
-    <p:bg>
-      <p:bgPr>
-        <a:solidFill>
-          <a:srgbClr val="161616"/>
-        </a:solidFill>
-        <a:effectLst/>
-      </p:bgPr>
-    </p:bg>
-    <p:spTree>
-      <p:nvGrpSpPr>
-        <p:cNvPr id="1" name="">
-          <a:extLst>
-            <a:ext uri="{FF2B5EF4-FFF2-40B4-BE49-F238E27FC236}">
-              <a16:creationId xmlns:a16="http://schemas.microsoft.com/office/drawing/2014/main" id="{A689CFC8-A3A8-916D-A336-952955F25725}"/>
-            </a:ext>
-          </a:extLst>
-        </p:cNvPr>
-        <p:cNvGrpSpPr/>
-        <p:nvPr/>
-      </p:nvGrpSpPr>
-      <p:grpSpPr>
-        <a:xfrm>
-          <a:off x="0" y="0"/>
-          <a:ext cx="0" cy="0"/>
-          <a:chOff x="0" y="0"/>
-          <a:chExt cx="0" cy="0"/>
-        </a:xfrm>
-      </p:grpSpPr>
-      <p:sp>
-        <p:nvSpPr>
-          <p:cNvPr id="2" name="Title Bar">
-            <a:extLst>
-              <a:ext uri="{FF2B5EF4-FFF2-40B4-BE49-F238E27FC236}">
-                <a16:creationId xmlns:a16="http://schemas.microsoft.com/office/drawing/2014/main" id="{71B3FEB2-270B-AECA-2F61-4B8159B6A1D0}"/>
-              </a:ext>
-            </a:extLst>
-          </p:cNvPr>
-          <p:cNvSpPr/>
-          <p:nvPr/>
-        </p:nvSpPr>
-        <p:spPr>
-          <a:xfrm>
-            <a:off x="731520" y="365760"/>
-            <a:ext cx="54864" cy="411480"/>
-          </a:xfrm>
-          <a:prstGeom prst="rect">
-            <a:avLst/>
-          </a:prstGeom>
-          <a:solidFill>
-            <a:srgbClr val="0F62FE"/>
-          </a:solidFill>
-          <a:ln>
-            <a:noFill/>
-          </a:ln>
-        </p:spPr>
-        <p:style>
-          <a:lnRef idx="1">
-            <a:schemeClr val="accent1"/>
-          </a:lnRef>
-          <a:fillRef idx="3">
-            <a:schemeClr val="accent1"/>
-          </a:fillRef>
-          <a:effectRef idx="2">
-            <a:schemeClr val="accent1"/>
-          </a:effectRef>
-          <a:fontRef idx="minor">
-            <a:schemeClr val="lt1"/>
-          </a:fontRef>
-        </p:style>
-        <p:txBody>
-          <a:bodyPr rtlCol="0" anchor="ctr"/>
-          <a:lstStyle/>
-          <a:p>
-            <a:pPr marL="0" marR="0" lvl="0" indent="0" algn="ctr" defTabSz="457200" rtl="0" eaLnBrk="1" fontAlgn="auto" latinLnBrk="0" hangingPunct="1">
-              <a:lnSpc>
-                <a:spcPct val="100000"/>
-              </a:lnSpc>
-              <a:spcBef>
-                <a:spcPts val="0"/>
-              </a:spcBef>
-              <a:spcAft>
-                <a:spcPts val="0"/>
-              </a:spcAft>
-              <a:buClrTx/>
-              <a:buSzTx/>
-              <a:buFontTx/>
-              <a:buNone/>
-              <a:tabLst/>
-              <a:defRPr/>
-            </a:pPr>
-            <a:endParaRPr kumimoji="0" sz="2800" b="0" i="0" u="none" strike="noStrike" kern="1200" cap="none" spc="0" normalizeH="0" baseline="0" noProof="0">
-              <a:ln>
-                <a:noFill/>
-              </a:ln>
-              <a:solidFill>
-                <a:prstClr val="white"/>
-              </a:solidFill>
-              <a:effectLst/>
-              <a:uLnTx/>
-              <a:uFillTx/>
-              <a:latin typeface="Calibri"/>
-              <a:ea typeface="+mn-ea"/>
-              <a:cs typeface="+mn-cs"/>
-            </a:endParaRPr>
-          </a:p>
-        </p:txBody>
-      </p:sp>
-      <p:sp>
-        <p:nvSpPr>
-          <p:cNvPr id="3" name="Title">
-            <a:extLst>
-              <a:ext uri="{FF2B5EF4-FFF2-40B4-BE49-F238E27FC236}">
-                <a16:creationId xmlns:a16="http://schemas.microsoft.com/office/drawing/2014/main" id="{E6B1F904-D0A5-1949-02B9-57928CCC86EC}"/>
-              </a:ext>
-            </a:extLst>
-          </p:cNvPr>
-          <p:cNvSpPr txBox="1"/>
-          <p:nvPr/>
-        </p:nvSpPr>
-        <p:spPr>
-          <a:xfrm>
-            <a:off x="960120" y="365760"/>
-            <a:ext cx="10000000" cy="502920"/>
-          </a:xfrm>
-          <a:prstGeom prst="rect">
-            <a:avLst/>
-          </a:prstGeom>
-          <a:noFill/>
-        </p:spPr>
-        <p:txBody>
-          <a:bodyPr wrap="square" lIns="0" tIns="0"/>
-          <a:lstStyle/>
-          <a:p>
-            <a:pPr marL="0" marR="0" lvl="0" indent="0" algn="l" defTabSz="457200" rtl="0" eaLnBrk="1" fontAlgn="auto" latinLnBrk="0" hangingPunct="1">
-              <a:lnSpc>
-                <a:spcPct val="100000"/>
-              </a:lnSpc>
-              <a:spcBef>
-                <a:spcPts val="0"/>
-              </a:spcBef>
-              <a:spcAft>
-                <a:spcPts val="0"/>
-              </a:spcAft>
-              <a:buClrTx/>
-              <a:buSzTx/>
-              <a:buFontTx/>
-              <a:buNone/>
-              <a:tabLst/>
-              <a:defRPr sz="2800" b="1">
-                <a:solidFill>
-                  <a:srgbClr val="FFFFFF"/>
-                </a:solidFill>
-                <a:latin typeface="Calibri"/>
-              </a:defRPr>
-            </a:pPr>
-            <a:r>
-              <a:rPr kumimoji="0" lang="en-US" sz="2800" b="1" i="0" u="none" strike="noStrike" kern="1200" cap="none" spc="0" normalizeH="0" baseline="0" noProof="0" dirty="0">
-                <a:ln>
-                  <a:noFill/>
-                </a:ln>
-                <a:solidFill>
-                  <a:srgbClr val="FFFFFF"/>
-                </a:solidFill>
-                <a:effectLst/>
-                <a:uLnTx/>
-                <a:uFillTx/>
-                <a:latin typeface="Calibri"/>
-                <a:ea typeface="+mn-ea"/>
-                <a:cs typeface="+mn-cs"/>
-              </a:rPr>
-              <a:t>Workshop Repo</a:t>
-            </a:r>
-            <a:endParaRPr kumimoji="0" sz="2800" b="1" i="0" u="none" strike="noStrike" kern="1200" cap="none" spc="0" normalizeH="0" baseline="0" noProof="0" dirty="0">
-              <a:ln>
-                <a:noFill/>
-              </a:ln>
-              <a:solidFill>
-                <a:srgbClr val="FFFFFF"/>
-              </a:solidFill>
-              <a:effectLst/>
-              <a:uLnTx/>
-              <a:uFillTx/>
-              <a:latin typeface="Calibri"/>
-              <a:ea typeface="+mn-ea"/>
-              <a:cs typeface="+mn-cs"/>
-            </a:endParaRPr>
-          </a:p>
-        </p:txBody>
-      </p:sp>
-      <p:sp>
-        <p:nvSpPr>
-          <p:cNvPr id="40" name="Footer">
-            <a:extLst>
-              <a:ext uri="{FF2B5EF4-FFF2-40B4-BE49-F238E27FC236}">
-                <a16:creationId xmlns:a16="http://schemas.microsoft.com/office/drawing/2014/main" id="{63B42C49-4F67-B960-894D-B774613D0BC8}"/>
-              </a:ext>
-            </a:extLst>
-          </p:cNvPr>
-          <p:cNvSpPr txBox="1"/>
-          <p:nvPr/>
-        </p:nvSpPr>
-        <p:spPr>
-          <a:xfrm>
-            <a:off x="3952262" y="5685060"/>
-            <a:ext cx="4287473" cy="411480"/>
-          </a:xfrm>
-          <a:prstGeom prst="rect">
-            <a:avLst/>
-          </a:prstGeom>
-          <a:noFill/>
-        </p:spPr>
-        <p:txBody>
-          <a:bodyPr wrap="square" lIns="0" tIns="0"/>
-          <a:lstStyle/>
-          <a:p>
-            <a:pPr marL="0" marR="0" lvl="0" indent="0" algn="ctr" defTabSz="457200" rtl="0" eaLnBrk="1" fontAlgn="auto" latinLnBrk="0" hangingPunct="1">
-              <a:lnSpc>
-                <a:spcPct val="100000"/>
-              </a:lnSpc>
-              <a:spcBef>
-                <a:spcPts val="0"/>
-              </a:spcBef>
-              <a:spcAft>
-                <a:spcPts val="0"/>
-              </a:spcAft>
-              <a:buClrTx/>
-              <a:buSzTx/>
-              <a:buFontTx/>
-              <a:buNone/>
-              <a:tabLst/>
-              <a:defRPr sz="1400" b="1" i="1">
-                <a:solidFill>
-                  <a:srgbClr val="78A9FF"/>
-                </a:solidFill>
-                <a:latin typeface="Calibri"/>
-              </a:defRPr>
-            </a:pPr>
-            <a:r>
-              <a:rPr lang="en-US" sz="2400" b="1" dirty="0" err="1">
-                <a:solidFill>
-                  <a:srgbClr val="78A9FF"/>
-                </a:solidFill>
-                <a:latin typeface="Calibri"/>
-              </a:rPr>
-              <a:t>i</a:t>
-            </a:r>
-            <a:r>
-              <a:rPr kumimoji="0" lang="en-US" sz="2400" b="1" u="none" strike="noStrike" kern="1200" cap="none" spc="0" normalizeH="0" baseline="0" noProof="0" dirty="0" err="1">
-                <a:ln>
-                  <a:noFill/>
-                </a:ln>
-                <a:solidFill>
-                  <a:srgbClr val="78A9FF"/>
-                </a:solidFill>
-                <a:effectLst/>
-                <a:uLnTx/>
-                <a:uFillTx/>
-                <a:latin typeface="Calibri"/>
-                <a:ea typeface="+mn-ea"/>
-                <a:cs typeface="+mn-cs"/>
-              </a:rPr>
-              <a:t>bm.biz</a:t>
-            </a:r>
-            <a:r>
-              <a:rPr kumimoji="0" lang="en-US" sz="2400" b="1" u="none" strike="noStrike" kern="1200" cap="none" spc="0" normalizeH="0" baseline="0" noProof="0" dirty="0">
-                <a:ln>
-                  <a:noFill/>
-                </a:ln>
-                <a:solidFill>
-                  <a:srgbClr val="78A9FF"/>
-                </a:solidFill>
-                <a:effectLst/>
-                <a:uLnTx/>
-                <a:uFillTx/>
-                <a:latin typeface="Calibri"/>
-                <a:ea typeface="+mn-ea"/>
-                <a:cs typeface="+mn-cs"/>
-              </a:rPr>
-              <a:t>/k8ssandra-claude-repo</a:t>
-            </a:r>
-            <a:endParaRPr kumimoji="0" sz="2400" b="1" u="none" strike="noStrike" kern="1200" cap="none" spc="0" normalizeH="0" baseline="0" noProof="0" dirty="0">
-              <a:ln>
-                <a:noFill/>
-              </a:ln>
-              <a:solidFill>
-                <a:srgbClr val="78A9FF"/>
-              </a:solidFill>
-              <a:effectLst/>
-              <a:uLnTx/>
-              <a:uFillTx/>
-              <a:latin typeface="Calibri"/>
-              <a:ea typeface="+mn-ea"/>
-              <a:cs typeface="+mn-cs"/>
-            </a:endParaRPr>
-          </a:p>
-        </p:txBody>
-      </p:sp>
-      <p:pic>
-        <p:nvPicPr>
-          <p:cNvPr id="7" name="Picture 6">
-            <a:extLst>
-              <a:ext uri="{FF2B5EF4-FFF2-40B4-BE49-F238E27FC236}">
-                <a16:creationId xmlns:a16="http://schemas.microsoft.com/office/drawing/2014/main" id="{5EC01F33-6E8B-BE1A-C94F-F59A2FBDEA7D}"/>
-              </a:ext>
-            </a:extLst>
-          </p:cNvPr>
-          <p:cNvPicPr>
-            <a:picLocks noChangeAspect="1"/>
-          </p:cNvPicPr>
-          <p:nvPr/>
-        </p:nvPicPr>
-        <p:blipFill>
-          <a:blip r:embed="rId2"/>
-          <a:stretch>
-            <a:fillRect/>
-          </a:stretch>
-        </p:blipFill>
-        <p:spPr>
-          <a:xfrm>
-            <a:off x="4182951" y="1515951"/>
-            <a:ext cx="3826097" cy="3826097"/>
-          </a:xfrm>
-          <a:prstGeom prst="rect">
-            <a:avLst/>
-          </a:prstGeom>
-        </p:spPr>
-      </p:pic>
-    </p:spTree>
-    <p:extLst>
-      <p:ext uri="{BB962C8B-B14F-4D97-AF65-F5344CB8AC3E}">
-        <p14:creationId xmlns:p14="http://schemas.microsoft.com/office/powerpoint/2010/main" val="2306626734"/>
-      </p:ext>
-    </p:extLst>
   </p:cSld>
   <p:clrMapOvr>
     <a:masterClrMapping/>
@@ -12256,7 +11922,7 @@
             </a:pPr>
             <a:r>
               <a:rPr sz="1100"/>
-              <a:t>~25 lines of declarative YAML</a:t>
+              <a:t>~100 lines of declarative YAML</a:t>
             </a:r>
           </a:p>
           <a:p>
@@ -12780,8 +12446,10 @@
               </a:defRPr>
             </a:pPr>
             <a:r>
-              <a:t>An umbrella project for running stock Apache Cassandra on Kubernetes</a:t>
-            </a:r>
+              <a:rPr lang="en-US" dirty="0"/>
+              <a:t>What are we even talking about here?</a:t>
+            </a:r>
+            <a:endParaRPr dirty="0"/>
           </a:p>
         </p:txBody>
       </p:sp>
@@ -12862,7 +12530,7 @@
               </a:defRPr>
             </a:pPr>
             <a:r>
-              <a:rPr sz="1400" b="1"/>
+              <a:rPr sz="1400" b="1" dirty="0"/>
               <a:t>An umbrella project</a:t>
             </a:r>
           </a:p>
@@ -12883,8 +12551,20 @@
               </a:defRPr>
             </a:pPr>
             <a:r>
-              <a:rPr sz="1200"/>
-              <a:t>cass-operator, k8ssandra-operator, management-api, Reaper, Medusa, metrics agent, client CLI</a:t>
+              <a:rPr sz="1200" dirty="0" err="1"/>
+              <a:t>cass</a:t>
+            </a:r>
+            <a:r>
+              <a:rPr sz="1200" dirty="0"/>
+              <a:t>-operator, k8ssandra-operator, management-</a:t>
+            </a:r>
+            <a:r>
+              <a:rPr sz="1200" dirty="0" err="1"/>
+              <a:t>api</a:t>
+            </a:r>
+            <a:r>
+              <a:rPr sz="1200" dirty="0"/>
+              <a:t>, Reaper, Medusa, metrics agent, client CLI</a:t>
             </a:r>
           </a:p>
           <a:p>
@@ -12904,7 +12584,7 @@
               </a:defRPr>
             </a:pPr>
             <a:r>
-              <a:rPr sz="1400" b="1"/>
+              <a:rPr sz="1400" b="1" dirty="0"/>
               <a:t>Stock Apache Cassandra 5.0.8</a:t>
             </a:r>
           </a:p>
@@ -12925,8 +12605,8 @@
               </a:defRPr>
             </a:pPr>
             <a:r>
-              <a:rPr sz="1200"/>
-              <a:t>The exact tarball you’d download — no patches, no vendor build</a:t>
+              <a:rPr sz="1200" dirty="0"/>
+              <a:t>Unmodified Apache binaries + the management agent — no patches, no vendor build</a:t>
             </a:r>
           </a:p>
           <a:p>
@@ -12946,7 +12626,7 @@
               </a:defRPr>
             </a:pPr>
             <a:r>
-              <a:rPr sz="1400" b="1"/>
+              <a:rPr sz="1400" b="1" dirty="0"/>
               <a:t>Community-owned, actively maintained</a:t>
             </a:r>
           </a:p>
@@ -12967,8 +12647,24 @@
               </a:defRPr>
             </a:pPr>
             <a:r>
-              <a:rPr sz="1200"/>
-              <a:t>Born from DataStax K8s work — same engineering that underpins Mission Control</a:t>
+              <a:rPr sz="1200" dirty="0"/>
+              <a:t>Born from DataStax</a:t>
+            </a:r>
+            <a:r>
+              <a:rPr lang="en-US" sz="1200" dirty="0"/>
+              <a:t> and other community</a:t>
+            </a:r>
+            <a:r>
+              <a:rPr sz="1200" dirty="0"/>
+              <a:t> </a:t>
+            </a:r>
+            <a:r>
+              <a:rPr lang="en-US" sz="1200" dirty="0"/>
+              <a:t>k</a:t>
+            </a:r>
+            <a:r>
+              <a:rPr sz="1200" dirty="0"/>
+              <a:t>8s work</a:t>
             </a:r>
           </a:p>
           <a:p>
@@ -12988,7 +12684,7 @@
               </a:defRPr>
             </a:pPr>
             <a:r>
-              <a:rPr sz="1400" b="1"/>
+              <a:rPr sz="1400" b="1" dirty="0"/>
               <a:t>Batteries included, Helm-installable</a:t>
             </a:r>
           </a:p>
@@ -13009,7 +12705,7 @@
               </a:defRPr>
             </a:pPr>
             <a:r>
-              <a:rPr sz="1200"/>
+              <a:rPr sz="1200" dirty="0"/>
               <a:t>Repairs, backups, metrics wired up out of the box — one Helm release</a:t>
             </a:r>
           </a:p>
@@ -13406,8 +13102,14 @@
               </a:defRPr>
             </a:pPr>
             <a:r>
-              <a:t>Six pieces that turn one CR into a running suite</a:t>
-            </a:r>
+              <a:rPr dirty="0"/>
+              <a:t>Six pieces that turn one CR into a running </a:t>
+            </a:r>
+            <a:r>
+              <a:rPr lang="en-US" dirty="0"/>
+              <a:t>database ecosystem</a:t>
+            </a:r>
+            <a:endParaRPr dirty="0"/>
           </a:p>
         </p:txBody>
       </p:sp>
@@ -13806,7 +13508,7 @@
             </a:pPr>
             <a:r>
               <a:rPr sz="1050"/>
-              <a:t>Sidecar in every Cassandra pod</a:t>
+              <a:t>Runs inside every Cassandra container</a:t>
             </a:r>
           </a:p>
           <a:p>
@@ -14066,7 +13768,7 @@
             </a:pPr>
             <a:r>
               <a:rPr sz="1050"/>
-              <a:t>Sidecar per pod. Uploads sstables to any S3-compatible bucket. AWS S3, GCS, NooBaa — portable</a:t>
+              <a:t>Sidecar per pod. Uploads sstables to any S3-compatible bucket. AWS S3, GCS, Azure, MinIO — portable</a:t>
             </a:r>
           </a:p>
         </p:txBody>
@@ -14351,7 +14053,7 @@
               </a:defRPr>
             </a:pPr>
             <a:r>
-              <a:t>~150 lines of YAML declare the whole platform</a:t>
+              <a:t>~100 lines of YAML declare the whole platform</a:t>
             </a:r>
           </a:p>
         </p:txBody>
@@ -14630,7 +14332,7 @@
             </a:pPr>
             <a:r>
               <a:rPr sz="1100"/>
-              <a:t>        storageConfig: { storageClass: ceph-rbd, 150Gi }</a:t>
+              <a:t>        storageConfig: { ocs-storagecluster-ceph-rbd, 150Gi }</a:t>
             </a:r>
           </a:p>
           <a:p>
@@ -14768,7 +14470,7 @@
             </a:pPr>
             <a:r>
               <a:rPr sz="1100"/>
-              <a:t>      host: s3.openshift-storage.svc</a:t>
+              <a:t>      host: minio.default.svc.cluster.local</a:t>
             </a:r>
           </a:p>
           <a:p>
@@ -14782,7 +14484,7 @@
             </a:pPr>
             <a:r>
               <a:rPr sz="1100"/>
-              <a:t>      bucketName: &lt;from OBC&gt;</a:t>
+              <a:t>      bucketName: medusa-backups</a:t>
             </a:r>
           </a:p>
         </p:txBody>
@@ -16290,7 +15992,7 @@
             </a:pPr>
             <a:r>
               <a:rPr sz="1050" dirty="0"/>
-              <a:t>svc: s3.openshift-storage.svc:443</a:t>
+              <a:t>svc: minio.default.svc:9000 (in-cluster HTTP)</a:t>
             </a:r>
           </a:p>
           <a:p>
@@ -16310,15 +16012,7 @@
             </a:pPr>
             <a:r>
               <a:rPr sz="1000" i="1" dirty="0"/>
-              <a:t>Provisioned via </a:t>
-            </a:r>
-            <a:r>
-              <a:rPr sz="1000" i="1" dirty="0" err="1"/>
-              <a:t>ObjectBucketClaim</a:t>
-            </a:r>
-            <a:r>
-              <a:rPr sz="1000" i="1" dirty="0"/>
-              <a:t> — no AWS, no IAM request</a:t>
+              <a:t>A Deployment + 250Gi Ceph RBD PVC — no AWS, no IAM request</a:t>
             </a:r>
           </a:p>
         </p:txBody>
@@ -17155,7 +16849,7 @@
                   <a:srgbClr val="8D8D8D"/>
                 </a:solidFill>
               </a:rPr>
-              <a:t>  demo-dc1-service  ·  demo-dc1-all-pods-service  ·  demo-dc1-contact-points  ·  demo-dc1-reaper  ·  easy-cass-mcp  ·  seed-services (headless)</a:t>
+              <a:t>  demo-dc1-{service, all-pods-service, contact-points-service, reaper-service}  ·  easy-cass-mcp  ·  minio  ·  demo-seed-service</a:t>
             </a:r>
           </a:p>
         </p:txBody>
@@ -17555,7 +17249,7 @@
             </a:pPr>
             <a:r>
               <a:rPr sz="1050"/>
-              <a:t>prepare: schema + 20M row load</a:t>
+              <a:t>prepare: schema + 50M rows per table</a:t>
             </a:r>
           </a:p>
           <a:p>
@@ -17575,7 +17269,7 @@
             </a:pPr>
             <a:r>
               <a:rPr sz="1050"/>
-              <a:t>sustained: 85/15 read/write, threads=400</a:t>
+              <a:t>sustained: 85/15 read/write, threads=600</a:t>
             </a:r>
           </a:p>
           <a:p>
@@ -17928,7 +17622,7 @@
             </a:pPr>
             <a:r>
               <a:rPr sz="950"/>
-              <a:t>Port 8000 (SSE)</a:t>
+              <a:t>Port 8000 (Streamable HTTP)</a:t>
             </a:r>
           </a:p>
           <a:p>
@@ -18488,7 +18182,7 @@
             </a:pPr>
             <a:r>
               <a:rPr sz="1100"/>
-              <a:t>StorageClass</a:t>
+              <a:t>cert-manager</a:t>
             </a:r>
           </a:p>
           <a:p>
@@ -18502,7 +18196,7 @@
             </a:pPr>
             <a:r>
               <a:rPr sz="850" i="1"/>
-              <a:t>ODF provides it</a:t>
+              <a:t>Helm chart</a:t>
             </a:r>
           </a:p>
         </p:txBody>
@@ -18537,7 +18231,7 @@
             </a:pPr>
             <a:r>
               <a:rPr sz="1000"/>
-              <a:t>instant</a:t>
+              <a:t>~2 min</a:t>
             </a:r>
           </a:p>
         </p:txBody>
@@ -18617,7 +18311,7 @@
             </a:pPr>
             <a:r>
               <a:rPr sz="1100"/>
-              <a:t>cert-manager</a:t>
+              <a:t>kube-prometheus-stack</a:t>
             </a:r>
           </a:p>
           <a:p>
@@ -18631,7 +18325,7 @@
             </a:pPr>
             <a:r>
               <a:rPr sz="850"/>
-              <a:t>Helm chart</a:t>
+              <a:t>--skip-crds</a:t>
             </a:r>
           </a:p>
         </p:txBody>
@@ -18666,7 +18360,7 @@
             </a:pPr>
             <a:r>
               <a:rPr sz="1000"/>
-              <a:t>~2 min</a:t>
+              <a:t>~3 min</a:t>
             </a:r>
           </a:p>
         </p:txBody>
@@ -18746,7 +18440,7 @@
             </a:pPr>
             <a:r>
               <a:rPr sz="1000"/>
-              <a:t>kube-prometheus-stack</a:t>
+              <a:t>k8ssandra-operator</a:t>
             </a:r>
           </a:p>
           <a:p>
@@ -18760,7 +18454,7 @@
             </a:pPr>
             <a:r>
               <a:rPr sz="900" b="1"/>
-              <a:t>--skip-crds</a:t>
+              <a:t>v1.33.0, ns default</a:t>
             </a:r>
           </a:p>
         </p:txBody>
@@ -18795,7 +18489,7 @@
             </a:pPr>
             <a:r>
               <a:rPr sz="1000"/>
-              <a:t>~3 min</a:t>
+              <a:t>~2 min</a:t>
             </a:r>
           </a:p>
         </p:txBody>
@@ -18875,7 +18569,7 @@
             </a:pPr>
             <a:r>
               <a:rPr sz="1000"/>
-              <a:t>k8ssandra-operator</a:t>
+              <a:t>MinIO</a:t>
             </a:r>
           </a:p>
           <a:p>
@@ -18889,7 +18583,7 @@
             </a:pPr>
             <a:r>
               <a:rPr sz="850"/>
-              <a:t>v1.33.0, ns default</a:t>
+              <a:t>Medusa’s S3 endpoint</a:t>
             </a:r>
           </a:p>
         </p:txBody>
@@ -18924,7 +18618,7 @@
             </a:pPr>
             <a:r>
               <a:rPr sz="1000"/>
-              <a:t>~2 min</a:t>
+              <a:t>~1 min</a:t>
             </a:r>
           </a:p>
         </p:txBody>
@@ -19004,7 +18698,7 @@
             </a:pPr>
             <a:r>
               <a:rPr sz="1000"/>
-              <a:t>ObjectBucketClaim</a:t>
+              <a:t>K8ssandraCluster</a:t>
             </a:r>
           </a:p>
           <a:p>
@@ -19018,7 +18712,7 @@
             </a:pPr>
             <a:r>
               <a:rPr sz="850"/>
-              <a:t>NooBaa bucket</a:t>
+              <a:t>CR: demo (v5.0.8)</a:t>
             </a:r>
           </a:p>
         </p:txBody>
@@ -19053,7 +18747,7 @@
             </a:pPr>
             <a:r>
               <a:rPr sz="1000"/>
-              <a:t>~1 min</a:t>
+              <a:t>~5-8 min</a:t>
             </a:r>
           </a:p>
         </p:txBody>
@@ -19133,7 +18827,7 @@
             </a:pPr>
             <a:r>
               <a:rPr sz="1000"/>
-              <a:t>K8ssandraCluster</a:t>
+              <a:t>Apps + Routes</a:t>
             </a:r>
           </a:p>
           <a:p>
@@ -19147,7 +18841,7 @@
             </a:pPr>
             <a:r>
               <a:rPr sz="850"/>
-              <a:t>CR: demo (v5.0.8)</a:t>
+              <a:t>MCP, NoSQLBench, Routes</a:t>
             </a:r>
           </a:p>
         </p:txBody>
@@ -19182,7 +18876,7 @@
             </a:pPr>
             <a:r>
               <a:rPr sz="1000"/>
-              <a:t>~5-8 min</a:t>
+              <a:t>~1 min</a:t>
             </a:r>
           </a:p>
         </p:txBody>
@@ -19262,7 +18956,7 @@
             </a:pPr>
             <a:r>
               <a:rPr sz="1000"/>
-              <a:t>Apps + Routes</a:t>
+              <a:t>Endpoints</a:t>
             </a:r>
           </a:p>
           <a:p>
@@ -19276,7 +18970,7 @@
             </a:pPr>
             <a:r>
               <a:rPr sz="850"/>
-              <a:t>MCP, Reaper, Grafana</a:t>
+              <a:t>print URLs + creds</a:t>
             </a:r>
           </a:p>
         </p:txBody>
@@ -19311,7 +19005,7 @@
             </a:pPr>
             <a:r>
               <a:rPr sz="1000"/>
-              <a:t>~1 min</a:t>
+              <a:t>instant</a:t>
             </a:r>
           </a:p>
         </p:txBody>
@@ -19548,7 +19242,7 @@
             </a:pPr>
             <a:r>
               <a:rPr sz="1150" b="1"/>
-              <a:t>OBC secret format</a:t>
+              <a:t>NooBaa couldn’t carry Medusa</a:t>
             </a:r>
           </a:p>
           <a:p>
@@ -19565,7 +19259,7 @@
             </a:pPr>
             <a:r>
               <a:rPr sz="1000"/>
-              <a:t>NooBaa emits AWS_*, Medusa wants INI `[default]`</a:t>
+              <a:t>MCG agent pods pinned at 400Mi, OOMKilled ~75 s into a full backup</a:t>
             </a:r>
           </a:p>
           <a:p>
@@ -19582,7 +19276,7 @@
             </a:pPr>
             <a:r>
               <a:rPr sz="1000" b="1"/>
-              <a:t>Fix: script translates in-place</a:t>
+              <a:t>Fix: MinIO on a Ceph RBD PVC</a:t>
             </a:r>
           </a:p>
         </p:txBody>
@@ -20346,7 +20040,7 @@
             </a:pPr>
             <a:r>
               <a:rPr sz="1100"/>
-              <a:t>replicas: 3</a:t>
+              <a:t>replicas: 1 each (3 StatefulSets)</a:t>
             </a:r>
           </a:p>
         </p:txBody>
@@ -20569,8 +20263,8 @@
               </a:defRPr>
             </a:pPr>
             <a:r>
-              <a:rPr sz="1200"/>
-              <a:t>StorageClass: ceph-rbd (ODF)</a:t>
+              <a:rPr sz="1000"/>
+              <a:t>ocs-storagecluster-ceph-rbd</a:t>
             </a:r>
           </a:p>
           <a:p>
@@ -20589,8 +20283,8 @@
               </a:defRPr>
             </a:pPr>
             <a:r>
-              <a:rPr sz="1100"/>
-              <a:t>provisioner: rbd.csi.ceph.com</a:t>
+              <a:rPr sz="800"/>
+              <a:t>openshift-storage.rbd.csi.ceph.com</a:t>
             </a:r>
           </a:p>
           <a:p>
@@ -20776,8 +20470,8 @@
               </a:defRPr>
             </a:pPr>
             <a:r>
-              <a:rPr sz="1100" dirty="0"/>
-              <a:t>server-data-rack1-sts-0</a:t>
+              <a:rPr sz="850" dirty="0"/>
+              <a:t>server-data-demo-dc1-rack1-sts-0</a:t>
             </a:r>
           </a:p>
           <a:p>
@@ -20855,8 +20549,8 @@
               </a:defRPr>
             </a:pPr>
             <a:r>
-              <a:rPr sz="1100" dirty="0"/>
-              <a:t>server-data-rack2-sts-0</a:t>
+              <a:rPr sz="850" dirty="0"/>
+              <a:t>server-data-demo-dc1-rack2-sts-0</a:t>
             </a:r>
           </a:p>
           <a:p>
@@ -20934,8 +20628,8 @@
               </a:defRPr>
             </a:pPr>
             <a:r>
-              <a:rPr sz="1100" dirty="0"/>
-              <a:t>server-data-rack3-sts-0</a:t>
+              <a:rPr sz="850" dirty="0"/>
+              <a:t>server-data-demo-dc1-rack3-sts-0</a:t>
             </a:r>
           </a:p>
           <a:p>
@@ -21915,7 +21609,7 @@
             </a:pPr>
             <a:r>
               <a:rPr sz="1050"/>
-              <a:t>MedusaConfiguration → NooBaa OBC</a:t>
+              <a:t>MedusaConfiguration → MinIO</a:t>
             </a:r>
           </a:p>
         </p:txBody>

</xml_diff>

<commit_message>
Deck: slide 5 line count, /expert on slide 16
Co-Authored-By: Claude Opus 5.5 (1M context) <noreply@anthropic.com>
</commit_message>
<xml_diff>
--- a/k8ssandra-reference-architecture.pptx
+++ b/k8ssandra-reference-architecture.pptx
@@ -9864,7 +9864,7 @@
               </a:defRPr>
             </a:pPr>
             <a:r>
-              <a:rPr sz="2400"/>
+              <a:rPr sz="2400" dirty="0"/>
               <a:t>/optimize</a:t>
             </a:r>
           </a:p>
@@ -9884,7 +9884,7 @@
               </a:defRPr>
             </a:pPr>
             <a:r>
-              <a:rPr sz="1100" i="1"/>
+              <a:rPr sz="1100" i="1" dirty="0"/>
               <a:t>Concrete deltas, ranked by impact</a:t>
             </a:r>
           </a:p>
@@ -9904,8 +9904,12 @@
               </a:defRPr>
             </a:pPr>
             <a:r>
-              <a:rPr sz="1100"/>
-              <a:t>cassandra.yaml + ALTER TABLE deltas</a:t>
+              <a:rPr sz="1100" dirty="0" err="1"/>
+              <a:t>cassandra.yaml</a:t>
+            </a:r>
+            <a:r>
+              <a:rPr sz="1100" dirty="0"/>
+              <a:t> + ALTER TABLE deltas</a:t>
             </a:r>
           </a:p>
           <a:p>
@@ -9924,7 +9928,7 @@
               </a:defRPr>
             </a:pPr>
             <a:r>
-              <a:rPr sz="1100"/>
+              <a:rPr sz="1100" dirty="0"/>
               <a:t>Each comes with reason and expected impact</a:t>
             </a:r>
           </a:p>
@@ -9944,7 +9948,7 @@
               </a:defRPr>
             </a:pPr>
             <a:r>
-              <a:rPr sz="1100"/>
+              <a:rPr sz="1100" dirty="0"/>
               <a:t>Tier 1 / Tier 2 / Tier 3 priority</a:t>
             </a:r>
           </a:p>
@@ -9964,7 +9968,7 @@
               </a:defRPr>
             </a:pPr>
             <a:r>
-              <a:rPr sz="1000" b="1"/>
+              <a:rPr sz="1000" b="1" dirty="0"/>
               <a:t>Live recommendation:</a:t>
             </a:r>
           </a:p>
@@ -9984,8 +9988,16 @@
               </a:defRPr>
             </a:pPr>
             <a:r>
-              <a:rPr sz="1000" i="1"/>
-              <a:t>“key_cache_size: 0 in operator default. Table requests caching: ALL — silently ignored. Fix to 100MiB. Expected: 92k → 110-120k ops/sec.”</a:t>
+              <a:rPr sz="1000" i="1" dirty="0"/>
+              <a:t>“</a:t>
+            </a:r>
+            <a:r>
+              <a:rPr sz="1000" i="1" dirty="0" err="1"/>
+              <a:t>key_cache_size</a:t>
+            </a:r>
+            <a:r>
+              <a:rPr sz="1000" i="1" dirty="0"/>
+              <a:t>: 0 in operator default. Table requests caching: ALL — silently ignored. Fix to 100MiB. Expected: 92k → 110-120k ops/sec.”</a:t>
             </a:r>
           </a:p>
         </p:txBody>
@@ -10078,9 +10090,14 @@
               </a:defRPr>
             </a:pPr>
             <a:r>
-              <a:rPr sz="1800"/>
-              <a:t>@cassandra-expert</a:t>
-            </a:r>
+              <a:rPr lang="en-US" sz="2400" dirty="0"/>
+              <a:t>/</a:t>
+            </a:r>
+            <a:r>
+              <a:rPr sz="2400" dirty="0"/>
+              <a:t>expert</a:t>
+            </a:r>
+            <a:endParaRPr sz="1800" dirty="0"/>
           </a:p>
           <a:p>
             <a:pPr algn="ctr">
@@ -10098,7 +10115,7 @@
               </a:defRPr>
             </a:pPr>
             <a:r>
-              <a:rPr sz="1100" i="1"/>
+              <a:rPr sz="1100" i="1" dirty="0"/>
               <a:t>Trade-offs and production-readiness</a:t>
             </a:r>
           </a:p>
@@ -10118,7 +10135,7 @@
               </a:defRPr>
             </a:pPr>
             <a:r>
-              <a:rPr sz="1100"/>
+              <a:rPr sz="1100" dirty="0"/>
               <a:t>Anti-patterns, defensible-vs-dangerous defaults</a:t>
             </a:r>
           </a:p>
@@ -10138,7 +10155,7 @@
               </a:defRPr>
             </a:pPr>
             <a:r>
-              <a:rPr sz="1100"/>
+              <a:rPr sz="1100" dirty="0"/>
               <a:t>Real C* community stances baked in</a:t>
             </a:r>
           </a:p>
@@ -10158,7 +10175,7 @@
               </a:defRPr>
             </a:pPr>
             <a:r>
-              <a:rPr sz="1100"/>
+              <a:rPr sz="1100" dirty="0"/>
               <a:t>“Here’s what I’d actually do, and why”</a:t>
             </a:r>
           </a:p>
@@ -10178,7 +10195,7 @@
               </a:defRPr>
             </a:pPr>
             <a:r>
-              <a:rPr sz="1000" b="1"/>
+              <a:rPr sz="1000" b="1" dirty="0"/>
               <a:t>Live quote:</a:t>
             </a:r>
           </a:p>
@@ -10198,8 +10215,16 @@
               </a:defRPr>
             </a:pPr>
             <a:r>
-              <a:rPr sz="1000" i="1"/>
-              <a:t>“softPodAntiAffinity is defensible only for dev/CI/workshop — not for any RF=3 cluster where availability matters.”</a:t>
+              <a:rPr sz="1000" i="1" dirty="0"/>
+              <a:t>“</a:t>
+            </a:r>
+            <a:r>
+              <a:rPr sz="1000" i="1" dirty="0" err="1"/>
+              <a:t>softPodAntiAffinity</a:t>
+            </a:r>
+            <a:r>
+              <a:rPr sz="1000" i="1" dirty="0"/>
+              <a:t> is defensible only for dev/CI/workshop — not for any RF=3 cluster where availability matters.”</a:t>
             </a:r>
           </a:p>
         </p:txBody>
@@ -14053,7 +14078,16 @@
               </a:defRPr>
             </a:pPr>
             <a:r>
-              <a:t>~100 lines of YAML declare the whole platform</a:t>
+              <a:rPr dirty="0"/>
+              <a:t>~1</a:t>
+            </a:r>
+            <a:r>
+              <a:rPr lang="en-US" dirty="0"/>
+              <a:t>5</a:t>
+            </a:r>
+            <a:r>
+              <a:rPr dirty="0"/>
+              <a:t>0 lines of YAML declare the whole platform</a:t>
             </a:r>
           </a:p>
         </p:txBody>

</xml_diff>